<commit_message>
Near-misses compare only edges a reader can see: text with nothing drawn around it keeps just the sides it's aligned and anchored to, a straight line's run lines up only with other lines, and a contained picture is placed where its image draws; a picture whose image has empty margins built in asks for the file to be trimmed, so Acme's logos are trimmed and the example's stored deck re-exported
Co-Authored-By: Claude Opus 5.5 <noreply@anthropic.com>
</commit_message>
<xml_diff>
--- a/src/Pintura.Tests/fixtures/pptx/example.pptx
+++ b/src/Pintura.Tests/fixtures/pptx/example.pptx
@@ -5,12 +5,12 @@
     <p:sldMasterId id="2147483648" r:id="rId1"/>
   </p:sldMasterIdLst>
   <p:sldIdLst>
-    <p:sldId id="257" r:id="R0f7a7f2847d44dbe"/>
-    <p:sldId id="258" r:id="R0f3718405daa4e87"/>
-    <p:sldId id="259" r:id="R6dbfe5e646ef4f68"/>
-    <p:sldId id="260" r:id="Refc7a691f3cf4e71"/>
-    <p:sldId id="261" r:id="Rdea3f1a7be2945d2"/>
-    <p:sldId id="262" r:id="Re74cf4e1c3f44ea0"/>
+    <p:sldId id="257" r:id="Rc59a1fd6d7734022"/>
+    <p:sldId id="258" r:id="R13f5b6c4568a4672"/>
+    <p:sldId id="259" r:id="R1f3e980d0fa7432c"/>
+    <p:sldId id="260" r:id="Rd1d2aef31aea407f"/>
+    <p:sldId id="261" r:id="R6e9fb098c9da4084"/>
+    <p:sldId id="262" r:id="Ra5f1d00656b64e20"/>
   </p:sldIdLst>
   <p:sldSz cx="12192000" cy="6858000"/>
   <p:notesSz cx="6858000" cy="9144000"/>
@@ -112,12 +112,12 @@
   <p:extLst>
     <p:ext uri="{521415D9-36F7-43E2-AB2F-B90AF26B5E84}">
       <p14:sectionLst xmlns:p14="http://schemas.microsoft.com/office/powerpoint/2010/main">
-        <p14:section name="Default Section" id="{EB517D1B-65D8-4535-ABFE-179DF76D74CD}">
+        <p14:section name="Default Section" id="{10FA900D-1A33-48F3-9FA4-91275880D35A}">
           <p14:sldIdLst>
             <p14:sldId id="257"/>
           </p14:sldIdLst>
         </p14:section>
-        <p14:section name="Financial performance" id="{D3456246-CC67-4510-90C0-7578374B9F7D}">
+        <p14:section name="Financial performance" id="{0E926F28-8F45-4472-A87D-DA231EB1A91A}">
           <p14:sldIdLst>
             <p14:sldId id="258"/>
             <p14:sldId id="259"/>
@@ -125,7 +125,7 @@
             <p14:sldId id="261"/>
           </p14:sldIdLst>
         </p14:section>
-        <p14:section name="Capital allocation" id="{9A0091CA-0537-41D6-914D-96BE12F5005C}">
+        <p14:section name="Capital allocation" id="{EFD0EBC2-78D9-4E49-A295-A78E240F1B69}">
           <p14:sldIdLst>
             <p14:sldId id="262"/>
           </p14:sldIdLst>
@@ -316,7 +316,7 @@
             </a:lvl1pPr>
           </a:lstStyle>
           <a:p>
-            <a:fld id="{08D90AE8-3CA7-4AAF-95B6-8DA5CD758FE5}" type="slidenum">
+            <a:fld id="{88E1C05B-AB4B-43DE-A05A-697D53465161}" type="slidenum">
               <a:rPr lang="en-US"/>
               <a:t>‹#›</a:t>
             </a:fld>
@@ -333,15 +333,15 @@
           <p:nvPr/>
         </p:nvPicPr>
         <p:blipFill>
-          <a:blip xmlns:r="http://schemas.openxmlformats.org/officeDocument/2006/relationships" r:embed="Ra405d37b2518448e"/>
+          <a:blip xmlns:r="http://schemas.openxmlformats.org/officeDocument/2006/relationships" r:embed="R0b73ab3d0d764cf0"/>
           <a:stretch>
             <a:fillRect/>
           </a:stretch>
         </p:blipFill>
         <p:spPr>
           <a:xfrm>
-            <a:off x="10871200" y="558800"/>
-            <a:ext cx="812800" cy="304800"/>
+            <a:off x="10871200" y="584200"/>
+            <a:ext cx="812800" cy="254000"/>
           </a:xfrm>
           <a:prstGeom prst="rect"/>
         </p:spPr>
@@ -533,7 +533,7 @@
             </a:lvl1pPr>
           </a:lstStyle>
           <a:p>
-            <a:fld id="{49E6AE90-00C2-49BF-8317-71768E6119A1}" type="slidenum">
+            <a:fld id="{D37B7401-F033-4F25-85D5-86D5EE6D71EA}" type="slidenum">
               <a:rPr lang="en-US"/>
               <a:t>‹#›</a:t>
             </a:fld>
@@ -550,15 +550,15 @@
           <p:nvPr/>
         </p:nvPicPr>
         <p:blipFill>
-          <a:blip xmlns:r="http://schemas.openxmlformats.org/officeDocument/2006/relationships" r:embed="Rc48550e043c94db7"/>
+          <a:blip xmlns:r="http://schemas.openxmlformats.org/officeDocument/2006/relationships" r:embed="R894a700b43f142b9"/>
           <a:stretch>
             <a:fillRect/>
           </a:stretch>
         </p:blipFill>
         <p:spPr>
           <a:xfrm>
-            <a:off x="10871200" y="558800"/>
-            <a:ext cx="812800" cy="304800"/>
+            <a:off x="10871200" y="584200"/>
+            <a:ext cx="812800" cy="254000"/>
           </a:xfrm>
           <a:prstGeom prst="rect"/>
         </p:spPr>
@@ -806,15 +806,15 @@
           <p:nvPr/>
         </p:nvPicPr>
         <p:blipFill>
-          <a:blip xmlns:r="http://schemas.openxmlformats.org/officeDocument/2006/relationships" r:embed="R947d4a2df4b0453f"/>
+          <a:blip xmlns:r="http://schemas.openxmlformats.org/officeDocument/2006/relationships" r:embed="R90d264d129124233"/>
           <a:stretch>
             <a:fillRect/>
           </a:stretch>
         </p:blipFill>
         <p:spPr>
           <a:xfrm>
-            <a:off x="846667" y="762000"/>
-            <a:ext cx="1354667" cy="508000"/>
+            <a:off x="762889" y="803910"/>
+            <a:ext cx="1353312" cy="421523"/>
           </a:xfrm>
           <a:prstGeom prst="rect"/>
         </p:spPr>
@@ -997,7 +997,7 @@
             </a:lvl1pPr>
           </a:lstStyle>
           <a:p>
-            <a:fld id="{C700967C-24D0-413C-8885-7E613E7198F0}" type="slidenum">
+            <a:fld id="{0F6928A0-5866-4081-865A-9C0BA0C2DB0E}" type="slidenum">
               <a:rPr lang="en-US"/>
               <a:t>‹#›</a:t>
             </a:fld>
@@ -1316,10 +1316,10 @@
   </p:cSld>
   <p:clrMap bg1="lt1" tx1="dk1" bg2="lt2" tx2="dk2" accent1="accent1" accent2="accent2" accent3="accent3" accent4="accent4" accent5="accent5" accent6="accent6" hlink="hlink" folHlink="folHlink"/>
   <p:sldLayoutIdLst>
-    <p:sldLayoutId id="2147483650" r:id="R2ed8ecf1bcd1445e"/>
-    <p:sldLayoutId id="2147483651" r:id="Reea3d4deb7ed43a3"/>
-    <p:sldLayoutId id="2147483652" r:id="R6edd952ecd6848d9"/>
-    <p:sldLayoutId id="2147483653" r:id="Rbae8a2e7c7ea4db8"/>
+    <p:sldLayoutId id="2147483650" r:id="R452f76d9d51b4e28"/>
+    <p:sldLayoutId id="2147483651" r:id="R3e0b28eed6a5468c"/>
+    <p:sldLayoutId id="2147483652" r:id="R2f07d9c47080400f"/>
+    <p:sldLayoutId id="2147483653" r:id="Rd32ad18a9a204930"/>
   </p:sldLayoutIdLst>
   <p:txStyles>
     <p:titleStyle>
@@ -2008,7 +2008,7 @@
     <c:plotVisOnly val="1"/>
     <c:dispBlanksAs val="gap"/>
   </c:chart>
-  <c:externalData xmlns:r="http://schemas.openxmlformats.org/officeDocument/2006/relationships" r:id="Rd3c4a8e397244a3b">
+  <c:externalData xmlns:r="http://schemas.openxmlformats.org/officeDocument/2006/relationships" r:id="R5dcb49a5d4294665">
     <c:autoUpdate val="0"/>
   </c:externalData>
 </c:chartSpace>
@@ -2244,7 +2244,7 @@
             </a:lvl1pPr>
           </a:lstStyle>
           <a:p xmlns:a="http://schemas.openxmlformats.org/drawingml/2006/main">
-            <a:fld id="{C700967C-24D0-413C-8885-7E613E7198F0}" type="slidenum">
+            <a:fld id="{0F6928A0-5866-4081-865A-9C0BA0C2DB0E}" type="slidenum">
               <a:rPr lang="en-US"/>
               <a:t>‹#›</a:t>
             </a:fld>
@@ -2851,7 +2851,7 @@
             </a:lvl1pPr>
           </a:lstStyle>
           <a:p xmlns:a="http://schemas.openxmlformats.org/drawingml/2006/main">
-            <a:fld id="{08D90AE8-3CA7-4AAF-95B6-8DA5CD758FE5}" type="slidenum">
+            <a:fld id="{88E1C05B-AB4B-43DE-A05A-697D53465161}" type="slidenum">
               <a:rPr lang="en-US"/>
               <a:t>‹#›</a:t>
             </a:fld>
@@ -2972,7 +2972,7 @@
         </p:xfrm>
         <a:graphic>
           <a:graphicData uri="http://schemas.openxmlformats.org/drawingml/2006/chart">
-            <c:chart xmlns:r="http://schemas.openxmlformats.org/officeDocument/2006/relationships" xmlns:c="http://schemas.openxmlformats.org/drawingml/2006/chart" r:id="R6bd119f09118459d"/>
+            <c:chart xmlns:r="http://schemas.openxmlformats.org/officeDocument/2006/relationships" xmlns:c="http://schemas.openxmlformats.org/drawingml/2006/chart" r:id="R5174035930364b67"/>
           </a:graphicData>
         </a:graphic>
       </p:graphicFrame>
@@ -3298,7 +3298,7 @@
             <a:r>
               <a:rPr sz="900" b="0" i="1">
                 <a:latin typeface="+mn-lt"/>
-                <a:hlinkClick xmlns:r="http://schemas.openxmlformats.org/officeDocument/2006/relationships" r:id="R80668817089444b7"/>
+                <a:hlinkClick xmlns:r="http://schemas.openxmlformats.org/officeDocument/2006/relationships" r:id="R1df65b21f54d40fe"/>
               </a:rPr>
               <a:t>Acme S-1/A</a:t>
             </a:r>
@@ -3365,7 +3365,7 @@
             </a:lvl1pPr>
           </a:lstStyle>
           <a:p xmlns:a="http://schemas.openxmlformats.org/drawingml/2006/main">
-            <a:fld id="{49E6AE90-00C2-49BF-8317-71768E6119A1}" type="slidenum">
+            <a:fld id="{D37B7401-F033-4F25-85D5-86D5EE6D71EA}" type="slidenum">
               <a:rPr lang="en-US"/>
               <a:t>‹#›</a:t>
             </a:fld>
@@ -5877,7 +5877,7 @@
             </a:lvl1pPr>
           </a:lstStyle>
           <a:p xmlns:a="http://schemas.openxmlformats.org/drawingml/2006/main">
-            <a:fld id="{49E6AE90-00C2-49BF-8317-71768E6119A1}" type="slidenum">
+            <a:fld id="{D37B7401-F033-4F25-85D5-86D5EE6D71EA}" type="slidenum">
               <a:rPr lang="en-US"/>
               <a:t>‹#›</a:t>
             </a:fld>
@@ -6821,7 +6821,7 @@
             </a:lvl1pPr>
           </a:lstStyle>
           <a:p xmlns:a="http://schemas.openxmlformats.org/drawingml/2006/main">
-            <a:fld id="{49E6AE90-00C2-49BF-8317-71768E6119A1}" type="slidenum">
+            <a:fld id="{D37B7401-F033-4F25-85D5-86D5EE6D71EA}" type="slidenum">
               <a:rPr lang="en-US"/>
               <a:t>‹#›</a:t>
             </a:fld>

</xml_diff>